<commit_message>
자료실: A.i 컨텐츠 결제 안내서(한/영) + 관리자용 사용설명서 10장 «AI 컨텐츠 결제» / Library: A.i content payment guide (KO/EN) + admin guide ch.10
- 대리점 자료실·관리자 자료실 맨 위에 «🤖 A.i 컨텐츠 결제 안내서»(A4 4쪽, 한/영 · 열기·저장·카톡 링크)
  /library/agency/ai-pay-guide-kr|en.pdf — 같은 파일을 두 자료실이 연다
- 사장님 PDF 는 로그인 사진에 실제 대리점 아이디가 있어 같은 구성으로 다시 만듦
  (시연 계정 testagency 캡처 · sample01 · 「2쪽 표」→「끝쪽 표」) — 원본 docs/자료실_원본/AI컨텐츠_결제안내/
- 관리자용 사용설명서 10장 «AI 컨텐츠 결제(대리점)» 6단계 + FAQ 3 → 10장 45단계, PDF/PPTX/XLSX 한/영 재생성
  1~9장 그림은 배포된 PPTX 에서 단계 제목으로 대조해 되살림(restore_images.py) — 글·그림 어긋남 방지
- 두 빌드가 쓰는 크로미움 띄우기·글꼴 심기를 docs/자료실_원본/_공용/pdf-helpers.mjs 로 모음(옛 chromium-1194 경로 하드코딩 제거)
- 작업기록·INDEX·CLAUDE.md 2장 함정 1줄(사람이 준 자료 속 실제 아이디)

Add the A.i content payment guide (A4, 4 pages, KO/EN) to the agency and admin libraries,
and add chapter 10 (A.i content payment) to the admin user guide (PDF/PPTX/XLSX, KO/EN).

Co-Authored-By: Claude Opus 5.5 <noreply@anthropic.com>
Claude-Session: https://claude.ai/code/session_015hjUTfinHmjG25a7d4k1UA
</commit_message>
<xml_diff>
--- a/cloudflare-deploy/public/library/admin/admin-en.pptx
+++ b/cloudflare-deploy/public/library/admin/admin-en.pptx
@@ -56,6 +56,13 @@
     <p:sldId id="304" r:id="rId55"/>
     <p:sldId id="305" r:id="rId56"/>
     <p:sldId id="306" r:id="rId57"/>
+    <p:sldId id="307" r:id="rId58"/>
+    <p:sldId id="308" r:id="rId59"/>
+    <p:sldId id="309" r:id="rId60"/>
+    <p:sldId id="310" r:id="rId61"/>
+    <p:sldId id="311" r:id="rId62"/>
+    <p:sldId id="312" r:id="rId63"/>
+    <p:sldId id="313" r:id="rId64"/>
   </p:sldIdLst>
   <p:sldSz cx="12191695" cy="6858000" type="screen4x3"/>
   <p:notesSz cx="6858000" cy="9144000"/>
@@ -3232,7 +3239,7 @@
                   <a:srgbClr val="F59E0B"/>
                 </a:solidFill>
               </a:rPr>
-              <a:t>As of 2026-10-09 · current screens</a:t>
+              <a:t>2026-10-28 edition · screens: ch. 1–9 2026-10-09 · ch. 10 2026-10-28</a:t>
             </a:r>
           </a:p>
         </p:txBody>
@@ -4727,6 +4734,14 @@
               <a:t>9. Approvals · Daily handover</a:t>
             </a:r>
           </a:p>
+          <a:p>
+            <a:pPr>
+              <a:defRPr sz="1600"/>
+            </a:pPr>
+            <a:r>
+              <a:t>10. A.i content payment (agencies)</a:t>
+            </a:r>
+          </a:p>
         </p:txBody>
       </p:sp>
     </p:spTree>
@@ -6191,7 +6206,7 @@
               <a:defRPr sz="1600"/>
             </a:pPr>
             <a:r>
-              <a:t>• The students, teachers (Emma Kim, Teacher Anna …) and numbers in the screenshots are sample data. Your screen shows real ones.</a:t>
+              <a:t>• The students, teachers and academies (Emma Kim, Teacher Anna, Sample English Academy, demo001 …) and numbers in the screenshots are sample data. Your screen shows real ones.</a:t>
             </a:r>
           </a:p>
           <a:p>
@@ -6199,7 +6214,7 @@
               <a:defRPr sz="1600"/>
             </a:pPr>
             <a:r>
-              <a:t>• Red box = the place to press.</a:t>
+              <a:t>• Red box = the place to press. In chapter 10 the numbers on the pictures (④⑤ …) match the numbers in the text.</a:t>
             </a:r>
           </a:p>
         </p:txBody>
@@ -9357,6 +9372,952 @@
             </a:pPr>
             <a:r>
               <a:t>• If you skip a workday, you and the CEO get a reminder next morning (holidays excluded).</a:t>
+            </a:r>
+          </a:p>
+        </p:txBody>
+      </p:sp>
+    </p:spTree>
+  </p:cSld>
+  <p:clrMapOvr>
+    <a:masterClrMapping/>
+  </p:clrMapOvr>
+</p:sld>
+</file>
+
+<file path=ppt/slides/slide52.xml><?xml version="1.0" encoding="utf-8"?>
+<p:sld xmlns:a="http://schemas.openxmlformats.org/drawingml/2006/main" xmlns:p="http://schemas.openxmlformats.org/presentationml/2006/main" xmlns:r="http://schemas.openxmlformats.org/officeDocument/2006/relationships">
+  <p:cSld>
+    <p:spTree>
+      <p:nvGrpSpPr>
+        <p:cNvPr id="1" name=""/>
+        <p:cNvGrpSpPr/>
+        <p:nvPr/>
+      </p:nvGrpSpPr>
+      <p:grpSpPr/>
+      <p:sp>
+        <p:nvSpPr>
+          <p:cNvPr id="2" name="Rectangle 1"/>
+          <p:cNvSpPr/>
+          <p:nvPr/>
+        </p:nvSpPr>
+        <p:spPr>
+          <a:xfrm>
+            <a:off x="0" y="0"/>
+            <a:ext cx="12191695" cy="6858000"/>
+          </a:xfrm>
+          <a:prstGeom prst="rect">
+            <a:avLst/>
+          </a:prstGeom>
+          <a:solidFill>
+            <a:srgbClr val="FFF7ED"/>
+          </a:solidFill>
+          <a:ln>
+            <a:noFill/>
+          </a:ln>
+        </p:spPr>
+        <p:style>
+          <a:lnRef idx="1">
+            <a:schemeClr val="accent1"/>
+          </a:lnRef>
+          <a:fillRef idx="3">
+            <a:schemeClr val="accent1"/>
+          </a:fillRef>
+          <a:effectRef idx="2">
+            <a:schemeClr val="accent1"/>
+          </a:effectRef>
+          <a:fontRef idx="minor">
+            <a:schemeClr val="lt1"/>
+          </a:fontRef>
+        </p:style>
+        <p:txBody>
+          <a:bodyPr rtlCol="0" anchor="ctr"/>
+          <a:lstStyle/>
+          <a:p>
+            <a:pPr algn="ctr"/>
+          </a:p>
+        </p:txBody>
+      </p:sp>
+      <p:sp>
+        <p:nvSpPr>
+          <p:cNvPr id="3" name="TextBox 2"/>
+          <p:cNvSpPr txBox="1"/>
+          <p:nvPr/>
+        </p:nvSpPr>
+        <p:spPr>
+          <a:xfrm>
+            <a:off x="731520" y="2377440"/>
+            <a:ext cx="10698480" cy="1097280"/>
+          </a:xfrm>
+          <a:prstGeom prst="rect">
+            <a:avLst/>
+          </a:prstGeom>
+          <a:noFill/>
+        </p:spPr>
+        <p:txBody>
+          <a:bodyPr wrap="square">
+            <a:spAutoFit/>
+          </a:bodyPr>
+          <a:lstStyle/>
+          <a:p>
+            <a:r>
+              <a:rPr sz="3600" b="1">
+                <a:solidFill>
+                  <a:srgbClr val="111827"/>
+                </a:solidFill>
+              </a:rPr>
+              <a:t>10. A.i content payment (agencies)</a:t>
+            </a:r>
+          </a:p>
+        </p:txBody>
+      </p:sp>
+      <p:sp>
+        <p:nvSpPr>
+          <p:cNvPr id="4" name="TextBox 3"/>
+          <p:cNvSpPr txBox="1"/>
+          <p:nvPr/>
+        </p:nvSpPr>
+        <p:spPr>
+          <a:xfrm>
+            <a:off x="731520" y="3474720"/>
+            <a:ext cx="10698480" cy="1280160"/>
+          </a:xfrm>
+          <a:prstGeom prst="rect">
+            <a:avLst/>
+          </a:prstGeom>
+          <a:noFill/>
+        </p:spPr>
+        <p:txBody>
+          <a:bodyPr wrap="square">
+            <a:spAutoFit/>
+          </a:bodyPr>
+          <a:lstStyle/>
+          <a:p>
+            <a:r>
+              <a:rPr sz="1800" b="0">
+                <a:solidFill>
+                  <a:srgbClr val="4B5563"/>
+                </a:solidFill>
+              </a:rPr>
+              <a:t>Agencies (academies) choose the students who will use A.i next month and pay by card by the last day of this month. Only agency accounts pay — HQ staff should know this flow to answer questions. The 4-page guide to send to agencies is «🤖 A.i Content Payment Guide» in the library.</a:t>
+            </a:r>
+          </a:p>
+        </p:txBody>
+      </p:sp>
+    </p:spTree>
+  </p:cSld>
+  <p:clrMapOvr>
+    <a:masterClrMapping/>
+  </p:clrMapOvr>
+</p:sld>
+</file>
+
+<file path=ppt/slides/slide53.xml><?xml version="1.0" encoding="utf-8"?>
+<p:sld xmlns:a="http://schemas.openxmlformats.org/drawingml/2006/main" xmlns:p="http://schemas.openxmlformats.org/presentationml/2006/main" xmlns:r="http://schemas.openxmlformats.org/officeDocument/2006/relationships">
+  <p:cSld>
+    <p:spTree>
+      <p:nvGrpSpPr>
+        <p:cNvPr id="1" name=""/>
+        <p:cNvGrpSpPr/>
+        <p:nvPr/>
+      </p:nvGrpSpPr>
+      <p:grpSpPr/>
+      <p:sp>
+        <p:nvSpPr>
+          <p:cNvPr id="2" name="TextBox 1"/>
+          <p:cNvSpPr txBox="1"/>
+          <p:nvPr/>
+        </p:nvSpPr>
+        <p:spPr>
+          <a:xfrm>
+            <a:off x="365760" y="228600"/>
+            <a:ext cx="11430000" cy="640080"/>
+          </a:xfrm>
+          <a:prstGeom prst="rect">
+            <a:avLst/>
+          </a:prstGeom>
+          <a:noFill/>
+        </p:spPr>
+        <p:txBody>
+          <a:bodyPr wrap="square">
+            <a:spAutoFit/>
+          </a:bodyPr>
+          <a:lstStyle/>
+          <a:p>
+            <a:r>
+              <a:rPr sz="2200" b="1">
+                <a:solidFill>
+                  <a:srgbClr val="111827"/>
+                </a:solidFill>
+              </a:rPr>
+              <a:t>10. A.i content payment (agencies) — Agency login · open the menu</a:t>
+            </a:r>
+          </a:p>
+        </p:txBody>
+      </p:sp>
+      <p:pic>
+        <p:nvPicPr>
+          <p:cNvPr id="3" name="Picture 2" descr="en-p2-menu.jpg"/>
+          <p:cNvPicPr>
+            <a:picLocks noChangeAspect="1"/>
+          </p:cNvPicPr>
+          <p:nvPr/>
+        </p:nvPicPr>
+        <p:blipFill>
+          <a:blip r:embed="rId2"/>
+          <a:stretch>
+            <a:fillRect/>
+          </a:stretch>
+        </p:blipFill>
+        <p:spPr>
+          <a:xfrm>
+            <a:off x="320040" y="960120"/>
+            <a:ext cx="7223760" cy="2498540"/>
+          </a:xfrm>
+          <a:prstGeom prst="rect">
+            <a:avLst/>
+          </a:prstGeom>
+        </p:spPr>
+      </p:pic>
+      <p:sp>
+        <p:nvSpPr>
+          <p:cNvPr id="4" name="TextBox 3"/>
+          <p:cNvSpPr txBox="1"/>
+          <p:nvPr/>
+        </p:nvSpPr>
+        <p:spPr>
+          <a:xfrm>
+            <a:off x="7772400" y="960120"/>
+            <a:ext cx="4114800" cy="5669280"/>
+          </a:xfrm>
+          <a:prstGeom prst="rect">
+            <a:avLst/>
+          </a:prstGeom>
+          <a:noFill/>
+        </p:spPr>
+        <p:txBody>
+          <a:bodyPr wrap="square">
+            <a:spAutoFit/>
+          </a:bodyPr>
+          <a:lstStyle/>
+          <a:p>
+            <a:pPr>
+              <a:spcAft>
+                <a:spcPts val="600"/>
+              </a:spcAft>
+              <a:defRPr sz="1400"/>
+            </a:pPr>
+            <a:r>
+              <a:t>• An agency logs in at mangoi.ai/admin/login with its agency ID and gets the agency screen.</a:t>
+            </a:r>
+          </a:p>
+          <a:p>
+            <a:pPr>
+              <a:spcAft>
+                <a:spcPts val="600"/>
+              </a:spcAft>
+              <a:defRPr sz="1400"/>
+            </a:pPr>
+            <a:r>
+              <a:t>• ④ Left menu Settlement &amp; stats › 🤖 A.i content payment. This menu appears only for agency accounts (not for HQ or branch accounts).</a:t>
+            </a:r>
+          </a:p>
+          <a:p>
+            <a:pPr>
+              <a:spcAft>
+                <a:spcPts val="600"/>
+              </a:spcAft>
+              <a:defRPr sz="1400"/>
+            </a:pPr>
+            <a:r>
+              <a:t>• HQ uses Finance › 🏢 AI Usage Fee (A.i Learning Fee Management) to see each academy’s headcount and estimated invoice, set custom rates, and turn auto-billing on or off. There is no pay button there.</a:t>
+            </a:r>
+          </a:p>
+        </p:txBody>
+      </p:sp>
+    </p:spTree>
+  </p:cSld>
+  <p:clrMapOvr>
+    <a:masterClrMapping/>
+  </p:clrMapOvr>
+</p:sld>
+</file>
+
+<file path=ppt/slides/slide54.xml><?xml version="1.0" encoding="utf-8"?>
+<p:sld xmlns:a="http://schemas.openxmlformats.org/drawingml/2006/main" xmlns:p="http://schemas.openxmlformats.org/presentationml/2006/main" xmlns:r="http://schemas.openxmlformats.org/officeDocument/2006/relationships">
+  <p:cSld>
+    <p:spTree>
+      <p:nvGrpSpPr>
+        <p:cNvPr id="1" name=""/>
+        <p:cNvGrpSpPr/>
+        <p:nvPr/>
+      </p:nvGrpSpPr>
+      <p:grpSpPr/>
+      <p:sp>
+        <p:nvSpPr>
+          <p:cNvPr id="2" name="TextBox 1"/>
+          <p:cNvSpPr txBox="1"/>
+          <p:nvPr/>
+        </p:nvSpPr>
+        <p:spPr>
+          <a:xfrm>
+            <a:off x="365760" y="228600"/>
+            <a:ext cx="11430000" cy="640080"/>
+          </a:xfrm>
+          <a:prstGeom prst="rect">
+            <a:avLst/>
+          </a:prstGeom>
+          <a:noFill/>
+        </p:spPr>
+        <p:txBody>
+          <a:bodyPr wrap="square">
+            <a:spAutoFit/>
+          </a:bodyPr>
+          <a:lstStyle/>
+          <a:p>
+            <a:r>
+              <a:rPr sz="2200" b="1">
+                <a:solidFill>
+                  <a:srgbClr val="111827"/>
+                </a:solidFill>
+              </a:rPr>
+              <a:t>10. A.i content payment (agencies) — Load the student list</a:t>
+            </a:r>
+          </a:p>
+        </p:txBody>
+      </p:sp>
+      <p:pic>
+        <p:nvPicPr>
+          <p:cNvPr id="3" name="Picture 2" descr="en-p3-load.jpg"/>
+          <p:cNvPicPr>
+            <a:picLocks noChangeAspect="1"/>
+          </p:cNvPicPr>
+          <p:nvPr/>
+        </p:nvPicPr>
+        <p:blipFill>
+          <a:blip r:embed="rId2"/>
+          <a:stretch>
+            <a:fillRect/>
+          </a:stretch>
+        </p:blipFill>
+        <p:spPr>
+          <a:xfrm>
+            <a:off x="320040" y="960120"/>
+            <a:ext cx="7223760" cy="3982425"/>
+          </a:xfrm>
+          <a:prstGeom prst="rect">
+            <a:avLst/>
+          </a:prstGeom>
+        </p:spPr>
+      </p:pic>
+      <p:sp>
+        <p:nvSpPr>
+          <p:cNvPr id="4" name="TextBox 3"/>
+          <p:cNvSpPr txBox="1"/>
+          <p:nvPr/>
+        </p:nvSpPr>
+        <p:spPr>
+          <a:xfrm>
+            <a:off x="7772400" y="960120"/>
+            <a:ext cx="4114800" cy="5669280"/>
+          </a:xfrm>
+          <a:prstGeom prst="rect">
+            <a:avLst/>
+          </a:prstGeom>
+          <a:noFill/>
+        </p:spPr>
+        <p:txBody>
+          <a:bodyPr wrap="square">
+            <a:spAutoFit/>
+          </a:bodyPr>
+          <a:lstStyle/>
+          <a:p>
+            <a:pPr>
+              <a:spcAft>
+                <a:spcPts val="600"/>
+              </a:spcAft>
+              <a:defRPr sz="1400"/>
+            </a:pPr>
+            <a:r>
+              <a:t>• Check the due date at the top (last day of this month · D-days left). The payment is for next month.</a:t>
+            </a:r>
+          </a:p>
+          <a:p>
+            <a:pPr>
+              <a:spcAft>
+                <a:spcPts val="600"/>
+              </a:spcAft>
+              <a:defRPr sz="1400"/>
+            </a:pPr>
+            <a:r>
+              <a:t>• Counters: Signed up for A.i (to be paid) · Not signed up · Video class (included) — video-class students get A.i with their tuition and are not paid here.</a:t>
+            </a:r>
+          </a:p>
+          <a:p>
+            <a:pPr>
+              <a:spcAft>
+                <a:spcPts val="600"/>
+              </a:spcAft>
+              <a:defRPr sz="1400"/>
+            </a:pPr>
+            <a:r>
+              <a:t>• ⑤ Load my students and choose only loads the list. Nothing is paid at this point.</a:t>
+            </a:r>
+          </a:p>
+          <a:p>
+            <a:pPr>
+              <a:spcAft>
+                <a:spcPts val="600"/>
+              </a:spcAft>
+              <a:defRPr sz="1400"/>
+            </a:pPr>
+            <a:r>
+              <a:t>• If HQ has not turned on auto-billing yet, the agency only sees «Head office has not opened A.i content payment yet (test period)» — it is not broken.</a:t>
+            </a:r>
+          </a:p>
+        </p:txBody>
+      </p:sp>
+    </p:spTree>
+  </p:cSld>
+  <p:clrMapOvr>
+    <a:masterClrMapping/>
+  </p:clrMapOvr>
+</p:sld>
+</file>
+
+<file path=ppt/slides/slide55.xml><?xml version="1.0" encoding="utf-8"?>
+<p:sld xmlns:a="http://schemas.openxmlformats.org/drawingml/2006/main" xmlns:p="http://schemas.openxmlformats.org/presentationml/2006/main" xmlns:r="http://schemas.openxmlformats.org/officeDocument/2006/relationships">
+  <p:cSld>
+    <p:spTree>
+      <p:nvGrpSpPr>
+        <p:cNvPr id="1" name=""/>
+        <p:cNvGrpSpPr/>
+        <p:nvPr/>
+      </p:nvGrpSpPr>
+      <p:grpSpPr/>
+      <p:sp>
+        <p:nvSpPr>
+          <p:cNvPr id="2" name="TextBox 1"/>
+          <p:cNvSpPr txBox="1"/>
+          <p:nvPr/>
+        </p:nvSpPr>
+        <p:spPr>
+          <a:xfrm>
+            <a:off x="365760" y="228600"/>
+            <a:ext cx="11430000" cy="640080"/>
+          </a:xfrm>
+          <a:prstGeom prst="rect">
+            <a:avLst/>
+          </a:prstGeom>
+          <a:noFill/>
+        </p:spPr>
+        <p:txBody>
+          <a:bodyPr wrap="square">
+            <a:spAutoFit/>
+          </a:bodyPr>
+          <a:lstStyle/>
+          <a:p>
+            <a:r>
+              <a:rPr sz="2200" b="1">
+                <a:solidFill>
+                  <a:srgbClr val="111827"/>
+                </a:solidFill>
+              </a:rPr>
+              <a:t>10. A.i content payment (agencies) — Choose next month’s students</a:t>
+            </a:r>
+          </a:p>
+        </p:txBody>
+      </p:sp>
+      <p:pic>
+        <p:nvPicPr>
+          <p:cNvPr id="3" name="Picture 2" descr="en-p4-check.jpg"/>
+          <p:cNvPicPr>
+            <a:picLocks noChangeAspect="1"/>
+          </p:cNvPicPr>
+          <p:nvPr/>
+        </p:nvPicPr>
+        <p:blipFill>
+          <a:blip r:embed="rId2"/>
+          <a:stretch>
+            <a:fillRect/>
+          </a:stretch>
+        </p:blipFill>
+        <p:spPr>
+          <a:xfrm>
+            <a:off x="320040" y="960120"/>
+            <a:ext cx="7223760" cy="3284926"/>
+          </a:xfrm>
+          <a:prstGeom prst="rect">
+            <a:avLst/>
+          </a:prstGeom>
+        </p:spPr>
+      </p:pic>
+      <p:sp>
+        <p:nvSpPr>
+          <p:cNvPr id="4" name="TextBox 3"/>
+          <p:cNvSpPr txBox="1"/>
+          <p:nvPr/>
+        </p:nvSpPr>
+        <p:spPr>
+          <a:xfrm>
+            <a:off x="7772400" y="960120"/>
+            <a:ext cx="4114800" cy="5669280"/>
+          </a:xfrm>
+          <a:prstGeom prst="rect">
+            <a:avLst/>
+          </a:prstGeom>
+          <a:noFill/>
+        </p:spPr>
+        <p:txBody>
+          <a:bodyPr wrap="square">
+            <a:spAutoFit/>
+          </a:bodyPr>
+          <a:lstStyle/>
+          <a:p>
+            <a:pPr>
+              <a:spcAft>
+                <a:spcPts val="600"/>
+              </a:spcAft>
+              <a:defRPr sz="1400"/>
+            </a:pPr>
+            <a:r>
+              <a:t>• ⑥ Only students checked under Paying for A.i content are paid. Unchecking a student who left removes them before payment.</a:t>
+            </a:r>
+          </a:p>
+          <a:p>
+            <a:pPr>
+              <a:spcAft>
+                <a:spcPts val="600"/>
+              </a:spcAft>
+              <a:defRPr sz="1400"/>
+            </a:pPr>
+            <a:r>
+              <a:t>• Search by name or ID; Unselect all shown / Select all shown changes many at once (it asks how many first).</a:t>
+            </a:r>
+          </a:p>
+          <a:p>
+            <a:pPr>
+              <a:spcAft>
+                <a:spcPts val="600"/>
+              </a:spcAft>
+              <a:defRPr sz="1400"/>
+            </a:pPr>
+            <a:r>
+              <a:t>• The server recalculates the amount every time a check changes.</a:t>
+            </a:r>
+          </a:p>
+        </p:txBody>
+      </p:sp>
+    </p:spTree>
+  </p:cSld>
+  <p:clrMapOvr>
+    <a:masterClrMapping/>
+  </p:clrMapOvr>
+</p:sld>
+</file>
+
+<file path=ppt/slides/slide56.xml><?xml version="1.0" encoding="utf-8"?>
+<p:sld xmlns:a="http://schemas.openxmlformats.org/drawingml/2006/main" xmlns:p="http://schemas.openxmlformats.org/presentationml/2006/main" xmlns:r="http://schemas.openxmlformats.org/officeDocument/2006/relationships">
+  <p:cSld>
+    <p:spTree>
+      <p:nvGrpSpPr>
+        <p:cNvPr id="1" name=""/>
+        <p:cNvGrpSpPr/>
+        <p:nvPr/>
+      </p:nvGrpSpPr>
+      <p:grpSpPr/>
+      <p:sp>
+        <p:nvSpPr>
+          <p:cNvPr id="2" name="TextBox 1"/>
+          <p:cNvSpPr txBox="1"/>
+          <p:nvPr/>
+        </p:nvSpPr>
+        <p:spPr>
+          <a:xfrm>
+            <a:off x="365760" y="228600"/>
+            <a:ext cx="11430000" cy="640080"/>
+          </a:xfrm>
+          <a:prstGeom prst="rect">
+            <a:avLst/>
+          </a:prstGeom>
+          <a:noFill/>
+        </p:spPr>
+        <p:txBody>
+          <a:bodyPr wrap="square">
+            <a:spAutoFit/>
+          </a:bodyPr>
+          <a:lstStyle/>
+          <a:p>
+            <a:r>
+              <a:rPr sz="2200" b="1">
+                <a:solidFill>
+                  <a:srgbClr val="111827"/>
+                </a:solidFill>
+              </a:rPr>
+              <a:t>10. A.i content payment (agencies) — Not signed up · video-class students</a:t>
+            </a:r>
+          </a:p>
+        </p:txBody>
+      </p:sp>
+      <p:pic>
+        <p:nvPicPr>
+          <p:cNvPr id="3" name="Picture 2" descr="en-p4-notyet.jpg"/>
+          <p:cNvPicPr>
+            <a:picLocks noChangeAspect="1"/>
+          </p:cNvPicPr>
+          <p:nvPr/>
+        </p:nvPicPr>
+        <p:blipFill>
+          <a:blip r:embed="rId2"/>
+          <a:stretch>
+            <a:fillRect/>
+          </a:stretch>
+        </p:blipFill>
+        <p:spPr>
+          <a:xfrm>
+            <a:off x="320040" y="960120"/>
+            <a:ext cx="7223760" cy="1845987"/>
+          </a:xfrm>
+          <a:prstGeom prst="rect">
+            <a:avLst/>
+          </a:prstGeom>
+        </p:spPr>
+      </p:pic>
+      <p:sp>
+        <p:nvSpPr>
+          <p:cNvPr id="4" name="TextBox 3"/>
+          <p:cNvSpPr txBox="1"/>
+          <p:nvPr/>
+        </p:nvSpPr>
+        <p:spPr>
+          <a:xfrm>
+            <a:off x="7772400" y="960120"/>
+            <a:ext cx="4114799" cy="5669280"/>
+          </a:xfrm>
+          <a:prstGeom prst="rect">
+            <a:avLst/>
+          </a:prstGeom>
+          <a:noFill/>
+        </p:spPr>
+        <p:txBody>
+          <a:bodyPr wrap="square">
+            <a:spAutoFit/>
+          </a:bodyPr>
+          <a:lstStyle/>
+          <a:p>
+            <a:pPr>
+              <a:spcAft>
+                <a:spcPts val="600"/>
+              </a:spcAft>
+              <a:defRPr sz="1400"/>
+            </a:pPr>
+            <a:r>
+              <a:t>• ⑦ Checking a student under Not signed up adds them to the payment.</a:t>
+            </a:r>
+          </a:p>
+          <a:p>
+            <a:pPr>
+              <a:spcAft>
+                <a:spcPts val="600"/>
+              </a:spcAft>
+              <a:defRPr sz="1400"/>
+            </a:pPr>
+            <a:r>
+              <a:t>• 📹 Video-class students are folded away. A.i is included in their tuition, so they are not chosen — check one only if the classification is wrong.</a:t>
+            </a:r>
+          </a:p>
+          <a:p>
+            <a:pPr>
+              <a:spcAft>
+                <a:spcPts val="600"/>
+              </a:spcAft>
+              <a:defRPr sz="1400"/>
+            </a:pPr>
+            <a:r>
+              <a:t>• Students the academy changed get a «✔ confirmed by academy» tag, and automatic classification no longer changes them.</a:t>
+            </a:r>
+          </a:p>
+        </p:txBody>
+      </p:sp>
+    </p:spTree>
+  </p:cSld>
+  <p:clrMapOvr>
+    <a:masterClrMapping/>
+  </p:clrMapOvr>
+</p:sld>
+</file>
+
+<file path=ppt/slides/slide57.xml><?xml version="1.0" encoding="utf-8"?>
+<p:sld xmlns:a="http://schemas.openxmlformats.org/drawingml/2006/main" xmlns:p="http://schemas.openxmlformats.org/presentationml/2006/main" xmlns:r="http://schemas.openxmlformats.org/officeDocument/2006/relationships">
+  <p:cSld>
+    <p:spTree>
+      <p:nvGrpSpPr>
+        <p:cNvPr id="1" name=""/>
+        <p:cNvGrpSpPr/>
+        <p:nvPr/>
+      </p:nvGrpSpPr>
+      <p:grpSpPr/>
+      <p:sp>
+        <p:nvSpPr>
+          <p:cNvPr id="2" name="TextBox 1"/>
+          <p:cNvSpPr txBox="1"/>
+          <p:nvPr/>
+        </p:nvSpPr>
+        <p:spPr>
+          <a:xfrm>
+            <a:off x="365760" y="228600"/>
+            <a:ext cx="11430000" cy="640080"/>
+          </a:xfrm>
+          <a:prstGeom prst="rect">
+            <a:avLst/>
+          </a:prstGeom>
+          <a:noFill/>
+        </p:spPr>
+        <p:txBody>
+          <a:bodyPr wrap="square">
+            <a:spAutoFit/>
+          </a:bodyPr>
+          <a:lstStyle/>
+          <a:p>
+            <a:r>
+              <a:rPr sz="2200" b="1">
+                <a:solidFill>
+                  <a:srgbClr val="111827"/>
+                </a:solidFill>
+              </a:rPr>
+              <a:t>10. A.i content payment (agencies) — Check the amount · pay by card</a:t>
+            </a:r>
+          </a:p>
+        </p:txBody>
+      </p:sp>
+      <p:pic>
+        <p:nvPicPr>
+          <p:cNvPr id="3" name="Picture 2" descr="en-p5-pay.jpg"/>
+          <p:cNvPicPr>
+            <a:picLocks noChangeAspect="1"/>
+          </p:cNvPicPr>
+          <p:nvPr/>
+        </p:nvPicPr>
+        <p:blipFill>
+          <a:blip r:embed="rId2"/>
+          <a:stretch>
+            <a:fillRect/>
+          </a:stretch>
+        </p:blipFill>
+        <p:spPr>
+          <a:xfrm>
+            <a:off x="320040" y="960120"/>
+            <a:ext cx="7223760" cy="3209724"/>
+          </a:xfrm>
+          <a:prstGeom prst="rect">
+            <a:avLst/>
+          </a:prstGeom>
+        </p:spPr>
+      </p:pic>
+      <p:sp>
+        <p:nvSpPr>
+          <p:cNvPr id="4" name="TextBox 3"/>
+          <p:cNvSpPr txBox="1"/>
+          <p:nvPr/>
+        </p:nvSpPr>
+        <p:spPr>
+          <a:xfrm>
+            <a:off x="7772400" y="960120"/>
+            <a:ext cx="4114800" cy="5669280"/>
+          </a:xfrm>
+          <a:prstGeom prst="rect">
+            <a:avLst/>
+          </a:prstGeom>
+          <a:noFill/>
+        </p:spPr>
+        <p:txBody>
+          <a:bodyPr wrap="square">
+            <a:spAutoFit/>
+          </a:bodyPr>
+          <a:lstStyle/>
+          <a:p>
+            <a:pPr>
+              <a:spcAft>
+                <a:spcPts val="600"/>
+              </a:spcAft>
+              <a:defRPr sz="1400"/>
+            </a:pPr>
+            <a:r>
+              <a:t>• ⑧ Check the number of students and the total, then ⑨ Pay OOO KRW → confirm → pay in the Toss card window.</a:t>
+            </a:r>
+          </a:p>
+          <a:p>
+            <a:pPr>
+              <a:spcAft>
+                <a:spcPts val="600"/>
+              </a:spcAft>
+              <a:defRPr sz="1400"/>
+            </a:pPr>
+            <a:r>
+              <a:t>• Price per student per month: 20 or fewer 7,500 · 21–50 6,500 · 51–70 5,500 · 71 or more 4,500 KRW. No minimum charge (since 2026-10-26).</a:t>
+            </a:r>
+          </a:p>
+          <a:p>
+            <a:pPr>
+              <a:spcAft>
+                <a:spcPts val="600"/>
+              </a:spcAft>
+              <a:defRPr sz="1400"/>
+            </a:pPr>
+            <a:r>
+              <a:t>• The total never goes down as students are added (e.g. 21–23 students = 150,000 KRW). The server recalculates the amount at the moment of payment — the screen number is for display. Academies with an HQ custom rate pay that rate × students.</a:t>
+            </a:r>
+          </a:p>
+          <a:p>
+            <a:pPr>
+              <a:spcAft>
+                <a:spcPts val="600"/>
+              </a:spcAft>
+              <a:defRPr sz="1400"/>
+            </a:pPr>
+            <a:r>
+              <a:t>• The demo account (testagency) does not open the payment window (sample data).</a:t>
+            </a:r>
+          </a:p>
+        </p:txBody>
+      </p:sp>
+    </p:spTree>
+  </p:cSld>
+  <p:clrMapOvr>
+    <a:masterClrMapping/>
+  </p:clrMapOvr>
+</p:sld>
+</file>
+
+<file path=ppt/slides/slide58.xml><?xml version="1.0" encoding="utf-8"?>
+<p:sld xmlns:a="http://schemas.openxmlformats.org/drawingml/2006/main" xmlns:p="http://schemas.openxmlformats.org/presentationml/2006/main" xmlns:r="http://schemas.openxmlformats.org/officeDocument/2006/relationships">
+  <p:cSld>
+    <p:spTree>
+      <p:nvGrpSpPr>
+        <p:cNvPr id="1" name=""/>
+        <p:cNvGrpSpPr/>
+        <p:nvPr/>
+      </p:nvGrpSpPr>
+      <p:grpSpPr/>
+      <p:sp>
+        <p:nvSpPr>
+          <p:cNvPr id="2" name="TextBox 1"/>
+          <p:cNvSpPr txBox="1"/>
+          <p:nvPr/>
+        </p:nvSpPr>
+        <p:spPr>
+          <a:xfrm>
+            <a:off x="365760" y="228600"/>
+            <a:ext cx="11430000" cy="640080"/>
+          </a:xfrm>
+          <a:prstGeom prst="rect">
+            <a:avLst/>
+          </a:prstGeom>
+          <a:noFill/>
+        </p:spPr>
+        <p:txBody>
+          <a:bodyPr wrap="square">
+            <a:spAutoFit/>
+          </a:bodyPr>
+          <a:lstStyle/>
+          <a:p>
+            <a:r>
+              <a:rPr sz="2200" b="1">
+                <a:solidFill>
+                  <a:srgbClr val="111827"/>
+                </a:solidFill>
+              </a:rPr>
+              <a:t>10. A.i content payment (agencies) — Check the payment · extra payment</a:t>
+            </a:r>
+          </a:p>
+        </p:txBody>
+      </p:sp>
+      <p:pic>
+        <p:nvPicPr>
+          <p:cNvPr id="3" name="Picture 2" descr="en-p6-done.jpg"/>
+          <p:cNvPicPr>
+            <a:picLocks noChangeAspect="1"/>
+          </p:cNvPicPr>
+          <p:nvPr/>
+        </p:nvPicPr>
+        <p:blipFill>
+          <a:blip r:embed="rId2"/>
+          <a:stretch>
+            <a:fillRect/>
+          </a:stretch>
+        </p:blipFill>
+        <p:spPr>
+          <a:xfrm>
+            <a:off x="320040" y="960120"/>
+            <a:ext cx="7223760" cy="1011477"/>
+          </a:xfrm>
+          <a:prstGeom prst="rect">
+            <a:avLst/>
+          </a:prstGeom>
+        </p:spPr>
+      </p:pic>
+      <p:sp>
+        <p:nvSpPr>
+          <p:cNvPr id="4" name="TextBox 3"/>
+          <p:cNvSpPr txBox="1"/>
+          <p:nvPr/>
+        </p:nvSpPr>
+        <p:spPr>
+          <a:xfrm>
+            <a:off x="7772400" y="960120"/>
+            <a:ext cx="4114800" cy="5669280"/>
+          </a:xfrm>
+          <a:prstGeom prst="rect">
+            <a:avLst/>
+          </a:prstGeom>
+          <a:noFill/>
+        </p:spPr>
+        <p:txBody>
+          <a:bodyPr wrap="square">
+            <a:spAutoFit/>
+          </a:bodyPr>
+          <a:lstStyle/>
+          <a:p>
+            <a:pPr>
+              <a:spcAft>
+                <a:spcPts val="600"/>
+              </a:spcAft>
+              <a:defRPr sz="1400"/>
+            </a:pPr>
+            <a:r>
+              <a:t>• ⑩ A ✅ under Past payments means paid. After paying, «Paid» appears and paid students are pinned at the top.</a:t>
+            </a:r>
+          </a:p>
+          <a:p>
+            <a:pPr>
+              <a:spcAft>
+                <a:spcPts val="600"/>
+              </a:spcAft>
+              <a:defRPr sz="1400"/>
+            </a:pPr>
+            <a:r>
+              <a:t>• To add students in the same month, check them below and press Pay extra — only the added students are charged.</a:t>
+            </a:r>
+          </a:p>
+          <a:p>
+            <a:pPr>
+              <a:spcAft>
+                <a:spcPts val="600"/>
+              </a:spcAft>
+              <a:defRPr sz="1400"/>
+            </a:pPr>
+            <a:r>
+              <a:t>• Students already paid for cannot be removed or changed on the screen. HQ handles refunds.</a:t>
+            </a:r>
+          </a:p>
+          <a:p>
+            <a:pPr>
+              <a:spcAft>
+                <a:spcPts val="600"/>
+              </a:spcAft>
+              <a:defRPr sz="1400"/>
+            </a:pPr>
+            <a:r>
+              <a:t>• If an earlier month is unpaid, a «⚠️ Unpaid A.i content invoice(s)» button appears at the top.</a:t>
             </a:r>
           </a:p>
         </p:txBody>

</xml_diff>

<commit_message>
자료실: A.i 컨텐츠 결제 안내서(한/영) + 관리자용 사용설명서 10장 «AI 컨텐츠 결제» / Library: A.i content payment guide (KO/EN) + admin guide ch.10 (#1847)
- 대리점 자료실·관리자 자료실 맨 위에 «🤖 A.i 컨텐츠 결제 안내서»(A4 4쪽, 한/영 · 열기·저장·카톡 링크)
  /library/agency/ai-pay-guide-kr|en.pdf — 같은 파일을 두 자료실이 연다
- 사장님 PDF 는 로그인 사진에 실제 대리점 아이디가 있어 같은 구성으로 다시 만듦
  (시연 계정 testagency 캡처 · sample01 · 「2쪽 표」→「끝쪽 표」) — 원본 docs/자료실_원본/AI컨텐츠_결제안내/
- 관리자용 사용설명서 10장 «AI 컨텐츠 결제(대리점)» 6단계 + FAQ 3 → 10장 45단계, PDF/PPTX/XLSX 한/영 재생성
  1~9장 그림은 배포된 PPTX 에서 단계 제목으로 대조해 되살림(restore_images.py) — 글·그림 어긋남 방지
- 두 빌드가 쓰는 크로미움 띄우기·글꼴 심기를 docs/자료실_원본/_공용/pdf-helpers.mjs 로 모음(옛 chromium-1194 경로 하드코딩 제거)
- 작업기록·INDEX·CLAUDE.md 2장 함정 1줄(사람이 준 자료 속 실제 아이디)

Add the A.i content payment guide (A4, 4 pages, KO/EN) to the agency and admin libraries,
and add chapter 10 (A.i content payment) to the admin user guide (PDF/PPTX/XLSX, KO/EN).


Claude-Session: https://claude.ai/code/session_015hjUTfinHmjG25a7d4k1UA

Co-authored-by: Claude <noreply@anthropic.com>
</commit_message>
<xml_diff>
--- a/cloudflare-deploy/public/library/admin/admin-en.pptx
+++ b/cloudflare-deploy/public/library/admin/admin-en.pptx
@@ -56,6 +56,13 @@
     <p:sldId id="304" r:id="rId55"/>
     <p:sldId id="305" r:id="rId56"/>
     <p:sldId id="306" r:id="rId57"/>
+    <p:sldId id="307" r:id="rId58"/>
+    <p:sldId id="308" r:id="rId59"/>
+    <p:sldId id="309" r:id="rId60"/>
+    <p:sldId id="310" r:id="rId61"/>
+    <p:sldId id="311" r:id="rId62"/>
+    <p:sldId id="312" r:id="rId63"/>
+    <p:sldId id="313" r:id="rId64"/>
   </p:sldIdLst>
   <p:sldSz cx="12191695" cy="6858000" type="screen4x3"/>
   <p:notesSz cx="6858000" cy="9144000"/>
@@ -3232,7 +3239,7 @@
                   <a:srgbClr val="F59E0B"/>
                 </a:solidFill>
               </a:rPr>
-              <a:t>As of 2026-10-09 · current screens</a:t>
+              <a:t>2026-10-28 edition · screens: ch. 1–9 2026-10-09 · ch. 10 2026-10-28</a:t>
             </a:r>
           </a:p>
         </p:txBody>
@@ -4727,6 +4734,14 @@
               <a:t>9. Approvals · Daily handover</a:t>
             </a:r>
           </a:p>
+          <a:p>
+            <a:pPr>
+              <a:defRPr sz="1600"/>
+            </a:pPr>
+            <a:r>
+              <a:t>10. A.i content payment (agencies)</a:t>
+            </a:r>
+          </a:p>
         </p:txBody>
       </p:sp>
     </p:spTree>
@@ -6191,7 +6206,7 @@
               <a:defRPr sz="1600"/>
             </a:pPr>
             <a:r>
-              <a:t>• The students, teachers (Emma Kim, Teacher Anna …) and numbers in the screenshots are sample data. Your screen shows real ones.</a:t>
+              <a:t>• The students, teachers and academies (Emma Kim, Teacher Anna, Sample English Academy, demo001 …) and numbers in the screenshots are sample data. Your screen shows real ones.</a:t>
             </a:r>
           </a:p>
           <a:p>
@@ -6199,7 +6214,7 @@
               <a:defRPr sz="1600"/>
             </a:pPr>
             <a:r>
-              <a:t>• Red box = the place to press.</a:t>
+              <a:t>• Red box = the place to press. In chapter 10 the numbers on the pictures (④⑤ …) match the numbers in the text.</a:t>
             </a:r>
           </a:p>
         </p:txBody>
@@ -9357,6 +9372,952 @@
             </a:pPr>
             <a:r>
               <a:t>• If you skip a workday, you and the CEO get a reminder next morning (holidays excluded).</a:t>
+            </a:r>
+          </a:p>
+        </p:txBody>
+      </p:sp>
+    </p:spTree>
+  </p:cSld>
+  <p:clrMapOvr>
+    <a:masterClrMapping/>
+  </p:clrMapOvr>
+</p:sld>
+</file>
+
+<file path=ppt/slides/slide52.xml><?xml version="1.0" encoding="utf-8"?>
+<p:sld xmlns:a="http://schemas.openxmlformats.org/drawingml/2006/main" xmlns:p="http://schemas.openxmlformats.org/presentationml/2006/main" xmlns:r="http://schemas.openxmlformats.org/officeDocument/2006/relationships">
+  <p:cSld>
+    <p:spTree>
+      <p:nvGrpSpPr>
+        <p:cNvPr id="1" name=""/>
+        <p:cNvGrpSpPr/>
+        <p:nvPr/>
+      </p:nvGrpSpPr>
+      <p:grpSpPr/>
+      <p:sp>
+        <p:nvSpPr>
+          <p:cNvPr id="2" name="Rectangle 1"/>
+          <p:cNvSpPr/>
+          <p:nvPr/>
+        </p:nvSpPr>
+        <p:spPr>
+          <a:xfrm>
+            <a:off x="0" y="0"/>
+            <a:ext cx="12191695" cy="6858000"/>
+          </a:xfrm>
+          <a:prstGeom prst="rect">
+            <a:avLst/>
+          </a:prstGeom>
+          <a:solidFill>
+            <a:srgbClr val="FFF7ED"/>
+          </a:solidFill>
+          <a:ln>
+            <a:noFill/>
+          </a:ln>
+        </p:spPr>
+        <p:style>
+          <a:lnRef idx="1">
+            <a:schemeClr val="accent1"/>
+          </a:lnRef>
+          <a:fillRef idx="3">
+            <a:schemeClr val="accent1"/>
+          </a:fillRef>
+          <a:effectRef idx="2">
+            <a:schemeClr val="accent1"/>
+          </a:effectRef>
+          <a:fontRef idx="minor">
+            <a:schemeClr val="lt1"/>
+          </a:fontRef>
+        </p:style>
+        <p:txBody>
+          <a:bodyPr rtlCol="0" anchor="ctr"/>
+          <a:lstStyle/>
+          <a:p>
+            <a:pPr algn="ctr"/>
+          </a:p>
+        </p:txBody>
+      </p:sp>
+      <p:sp>
+        <p:nvSpPr>
+          <p:cNvPr id="3" name="TextBox 2"/>
+          <p:cNvSpPr txBox="1"/>
+          <p:nvPr/>
+        </p:nvSpPr>
+        <p:spPr>
+          <a:xfrm>
+            <a:off x="731520" y="2377440"/>
+            <a:ext cx="10698480" cy="1097280"/>
+          </a:xfrm>
+          <a:prstGeom prst="rect">
+            <a:avLst/>
+          </a:prstGeom>
+          <a:noFill/>
+        </p:spPr>
+        <p:txBody>
+          <a:bodyPr wrap="square">
+            <a:spAutoFit/>
+          </a:bodyPr>
+          <a:lstStyle/>
+          <a:p>
+            <a:r>
+              <a:rPr sz="3600" b="1">
+                <a:solidFill>
+                  <a:srgbClr val="111827"/>
+                </a:solidFill>
+              </a:rPr>
+              <a:t>10. A.i content payment (agencies)</a:t>
+            </a:r>
+          </a:p>
+        </p:txBody>
+      </p:sp>
+      <p:sp>
+        <p:nvSpPr>
+          <p:cNvPr id="4" name="TextBox 3"/>
+          <p:cNvSpPr txBox="1"/>
+          <p:nvPr/>
+        </p:nvSpPr>
+        <p:spPr>
+          <a:xfrm>
+            <a:off x="731520" y="3474720"/>
+            <a:ext cx="10698480" cy="1280160"/>
+          </a:xfrm>
+          <a:prstGeom prst="rect">
+            <a:avLst/>
+          </a:prstGeom>
+          <a:noFill/>
+        </p:spPr>
+        <p:txBody>
+          <a:bodyPr wrap="square">
+            <a:spAutoFit/>
+          </a:bodyPr>
+          <a:lstStyle/>
+          <a:p>
+            <a:r>
+              <a:rPr sz="1800" b="0">
+                <a:solidFill>
+                  <a:srgbClr val="4B5563"/>
+                </a:solidFill>
+              </a:rPr>
+              <a:t>Agencies (academies) choose the students who will use A.i next month and pay by card by the last day of this month. Only agency accounts pay — HQ staff should know this flow to answer questions. The 4-page guide to send to agencies is «🤖 A.i Content Payment Guide» in the library.</a:t>
+            </a:r>
+          </a:p>
+        </p:txBody>
+      </p:sp>
+    </p:spTree>
+  </p:cSld>
+  <p:clrMapOvr>
+    <a:masterClrMapping/>
+  </p:clrMapOvr>
+</p:sld>
+</file>
+
+<file path=ppt/slides/slide53.xml><?xml version="1.0" encoding="utf-8"?>
+<p:sld xmlns:a="http://schemas.openxmlformats.org/drawingml/2006/main" xmlns:p="http://schemas.openxmlformats.org/presentationml/2006/main" xmlns:r="http://schemas.openxmlformats.org/officeDocument/2006/relationships">
+  <p:cSld>
+    <p:spTree>
+      <p:nvGrpSpPr>
+        <p:cNvPr id="1" name=""/>
+        <p:cNvGrpSpPr/>
+        <p:nvPr/>
+      </p:nvGrpSpPr>
+      <p:grpSpPr/>
+      <p:sp>
+        <p:nvSpPr>
+          <p:cNvPr id="2" name="TextBox 1"/>
+          <p:cNvSpPr txBox="1"/>
+          <p:nvPr/>
+        </p:nvSpPr>
+        <p:spPr>
+          <a:xfrm>
+            <a:off x="365760" y="228600"/>
+            <a:ext cx="11430000" cy="640080"/>
+          </a:xfrm>
+          <a:prstGeom prst="rect">
+            <a:avLst/>
+          </a:prstGeom>
+          <a:noFill/>
+        </p:spPr>
+        <p:txBody>
+          <a:bodyPr wrap="square">
+            <a:spAutoFit/>
+          </a:bodyPr>
+          <a:lstStyle/>
+          <a:p>
+            <a:r>
+              <a:rPr sz="2200" b="1">
+                <a:solidFill>
+                  <a:srgbClr val="111827"/>
+                </a:solidFill>
+              </a:rPr>
+              <a:t>10. A.i content payment (agencies) — Agency login · open the menu</a:t>
+            </a:r>
+          </a:p>
+        </p:txBody>
+      </p:sp>
+      <p:pic>
+        <p:nvPicPr>
+          <p:cNvPr id="3" name="Picture 2" descr="en-p2-menu.jpg"/>
+          <p:cNvPicPr>
+            <a:picLocks noChangeAspect="1"/>
+          </p:cNvPicPr>
+          <p:nvPr/>
+        </p:nvPicPr>
+        <p:blipFill>
+          <a:blip r:embed="rId2"/>
+          <a:stretch>
+            <a:fillRect/>
+          </a:stretch>
+        </p:blipFill>
+        <p:spPr>
+          <a:xfrm>
+            <a:off x="320040" y="960120"/>
+            <a:ext cx="7223760" cy="2498540"/>
+          </a:xfrm>
+          <a:prstGeom prst="rect">
+            <a:avLst/>
+          </a:prstGeom>
+        </p:spPr>
+      </p:pic>
+      <p:sp>
+        <p:nvSpPr>
+          <p:cNvPr id="4" name="TextBox 3"/>
+          <p:cNvSpPr txBox="1"/>
+          <p:nvPr/>
+        </p:nvSpPr>
+        <p:spPr>
+          <a:xfrm>
+            <a:off x="7772400" y="960120"/>
+            <a:ext cx="4114800" cy="5669280"/>
+          </a:xfrm>
+          <a:prstGeom prst="rect">
+            <a:avLst/>
+          </a:prstGeom>
+          <a:noFill/>
+        </p:spPr>
+        <p:txBody>
+          <a:bodyPr wrap="square">
+            <a:spAutoFit/>
+          </a:bodyPr>
+          <a:lstStyle/>
+          <a:p>
+            <a:pPr>
+              <a:spcAft>
+                <a:spcPts val="600"/>
+              </a:spcAft>
+              <a:defRPr sz="1400"/>
+            </a:pPr>
+            <a:r>
+              <a:t>• An agency logs in at mangoi.ai/admin/login with its agency ID and gets the agency screen.</a:t>
+            </a:r>
+          </a:p>
+          <a:p>
+            <a:pPr>
+              <a:spcAft>
+                <a:spcPts val="600"/>
+              </a:spcAft>
+              <a:defRPr sz="1400"/>
+            </a:pPr>
+            <a:r>
+              <a:t>• ④ Left menu Settlement &amp; stats › 🤖 A.i content payment. This menu appears only for agency accounts (not for HQ or branch accounts).</a:t>
+            </a:r>
+          </a:p>
+          <a:p>
+            <a:pPr>
+              <a:spcAft>
+                <a:spcPts val="600"/>
+              </a:spcAft>
+              <a:defRPr sz="1400"/>
+            </a:pPr>
+            <a:r>
+              <a:t>• HQ uses Finance › 🏢 AI Usage Fee (A.i Learning Fee Management) to see each academy’s headcount and estimated invoice, set custom rates, and turn auto-billing on or off. There is no pay button there.</a:t>
+            </a:r>
+          </a:p>
+        </p:txBody>
+      </p:sp>
+    </p:spTree>
+  </p:cSld>
+  <p:clrMapOvr>
+    <a:masterClrMapping/>
+  </p:clrMapOvr>
+</p:sld>
+</file>
+
+<file path=ppt/slides/slide54.xml><?xml version="1.0" encoding="utf-8"?>
+<p:sld xmlns:a="http://schemas.openxmlformats.org/drawingml/2006/main" xmlns:p="http://schemas.openxmlformats.org/presentationml/2006/main" xmlns:r="http://schemas.openxmlformats.org/officeDocument/2006/relationships">
+  <p:cSld>
+    <p:spTree>
+      <p:nvGrpSpPr>
+        <p:cNvPr id="1" name=""/>
+        <p:cNvGrpSpPr/>
+        <p:nvPr/>
+      </p:nvGrpSpPr>
+      <p:grpSpPr/>
+      <p:sp>
+        <p:nvSpPr>
+          <p:cNvPr id="2" name="TextBox 1"/>
+          <p:cNvSpPr txBox="1"/>
+          <p:nvPr/>
+        </p:nvSpPr>
+        <p:spPr>
+          <a:xfrm>
+            <a:off x="365760" y="228600"/>
+            <a:ext cx="11430000" cy="640080"/>
+          </a:xfrm>
+          <a:prstGeom prst="rect">
+            <a:avLst/>
+          </a:prstGeom>
+          <a:noFill/>
+        </p:spPr>
+        <p:txBody>
+          <a:bodyPr wrap="square">
+            <a:spAutoFit/>
+          </a:bodyPr>
+          <a:lstStyle/>
+          <a:p>
+            <a:r>
+              <a:rPr sz="2200" b="1">
+                <a:solidFill>
+                  <a:srgbClr val="111827"/>
+                </a:solidFill>
+              </a:rPr>
+              <a:t>10. A.i content payment (agencies) — Load the student list</a:t>
+            </a:r>
+          </a:p>
+        </p:txBody>
+      </p:sp>
+      <p:pic>
+        <p:nvPicPr>
+          <p:cNvPr id="3" name="Picture 2" descr="en-p3-load.jpg"/>
+          <p:cNvPicPr>
+            <a:picLocks noChangeAspect="1"/>
+          </p:cNvPicPr>
+          <p:nvPr/>
+        </p:nvPicPr>
+        <p:blipFill>
+          <a:blip r:embed="rId2"/>
+          <a:stretch>
+            <a:fillRect/>
+          </a:stretch>
+        </p:blipFill>
+        <p:spPr>
+          <a:xfrm>
+            <a:off x="320040" y="960120"/>
+            <a:ext cx="7223760" cy="3982425"/>
+          </a:xfrm>
+          <a:prstGeom prst="rect">
+            <a:avLst/>
+          </a:prstGeom>
+        </p:spPr>
+      </p:pic>
+      <p:sp>
+        <p:nvSpPr>
+          <p:cNvPr id="4" name="TextBox 3"/>
+          <p:cNvSpPr txBox="1"/>
+          <p:nvPr/>
+        </p:nvSpPr>
+        <p:spPr>
+          <a:xfrm>
+            <a:off x="7772400" y="960120"/>
+            <a:ext cx="4114800" cy="5669280"/>
+          </a:xfrm>
+          <a:prstGeom prst="rect">
+            <a:avLst/>
+          </a:prstGeom>
+          <a:noFill/>
+        </p:spPr>
+        <p:txBody>
+          <a:bodyPr wrap="square">
+            <a:spAutoFit/>
+          </a:bodyPr>
+          <a:lstStyle/>
+          <a:p>
+            <a:pPr>
+              <a:spcAft>
+                <a:spcPts val="600"/>
+              </a:spcAft>
+              <a:defRPr sz="1400"/>
+            </a:pPr>
+            <a:r>
+              <a:t>• Check the due date at the top (last day of this month · D-days left). The payment is for next month.</a:t>
+            </a:r>
+          </a:p>
+          <a:p>
+            <a:pPr>
+              <a:spcAft>
+                <a:spcPts val="600"/>
+              </a:spcAft>
+              <a:defRPr sz="1400"/>
+            </a:pPr>
+            <a:r>
+              <a:t>• Counters: Signed up for A.i (to be paid) · Not signed up · Video class (included) — video-class students get A.i with their tuition and are not paid here.</a:t>
+            </a:r>
+          </a:p>
+          <a:p>
+            <a:pPr>
+              <a:spcAft>
+                <a:spcPts val="600"/>
+              </a:spcAft>
+              <a:defRPr sz="1400"/>
+            </a:pPr>
+            <a:r>
+              <a:t>• ⑤ Load my students and choose only loads the list. Nothing is paid at this point.</a:t>
+            </a:r>
+          </a:p>
+          <a:p>
+            <a:pPr>
+              <a:spcAft>
+                <a:spcPts val="600"/>
+              </a:spcAft>
+              <a:defRPr sz="1400"/>
+            </a:pPr>
+            <a:r>
+              <a:t>• If HQ has not turned on auto-billing yet, the agency only sees «Head office has not opened A.i content payment yet (test period)» — it is not broken.</a:t>
+            </a:r>
+          </a:p>
+        </p:txBody>
+      </p:sp>
+    </p:spTree>
+  </p:cSld>
+  <p:clrMapOvr>
+    <a:masterClrMapping/>
+  </p:clrMapOvr>
+</p:sld>
+</file>
+
+<file path=ppt/slides/slide55.xml><?xml version="1.0" encoding="utf-8"?>
+<p:sld xmlns:a="http://schemas.openxmlformats.org/drawingml/2006/main" xmlns:p="http://schemas.openxmlformats.org/presentationml/2006/main" xmlns:r="http://schemas.openxmlformats.org/officeDocument/2006/relationships">
+  <p:cSld>
+    <p:spTree>
+      <p:nvGrpSpPr>
+        <p:cNvPr id="1" name=""/>
+        <p:cNvGrpSpPr/>
+        <p:nvPr/>
+      </p:nvGrpSpPr>
+      <p:grpSpPr/>
+      <p:sp>
+        <p:nvSpPr>
+          <p:cNvPr id="2" name="TextBox 1"/>
+          <p:cNvSpPr txBox="1"/>
+          <p:nvPr/>
+        </p:nvSpPr>
+        <p:spPr>
+          <a:xfrm>
+            <a:off x="365760" y="228600"/>
+            <a:ext cx="11430000" cy="640080"/>
+          </a:xfrm>
+          <a:prstGeom prst="rect">
+            <a:avLst/>
+          </a:prstGeom>
+          <a:noFill/>
+        </p:spPr>
+        <p:txBody>
+          <a:bodyPr wrap="square">
+            <a:spAutoFit/>
+          </a:bodyPr>
+          <a:lstStyle/>
+          <a:p>
+            <a:r>
+              <a:rPr sz="2200" b="1">
+                <a:solidFill>
+                  <a:srgbClr val="111827"/>
+                </a:solidFill>
+              </a:rPr>
+              <a:t>10. A.i content payment (agencies) — Choose next month’s students</a:t>
+            </a:r>
+          </a:p>
+        </p:txBody>
+      </p:sp>
+      <p:pic>
+        <p:nvPicPr>
+          <p:cNvPr id="3" name="Picture 2" descr="en-p4-check.jpg"/>
+          <p:cNvPicPr>
+            <a:picLocks noChangeAspect="1"/>
+          </p:cNvPicPr>
+          <p:nvPr/>
+        </p:nvPicPr>
+        <p:blipFill>
+          <a:blip r:embed="rId2"/>
+          <a:stretch>
+            <a:fillRect/>
+          </a:stretch>
+        </p:blipFill>
+        <p:spPr>
+          <a:xfrm>
+            <a:off x="320040" y="960120"/>
+            <a:ext cx="7223760" cy="3284926"/>
+          </a:xfrm>
+          <a:prstGeom prst="rect">
+            <a:avLst/>
+          </a:prstGeom>
+        </p:spPr>
+      </p:pic>
+      <p:sp>
+        <p:nvSpPr>
+          <p:cNvPr id="4" name="TextBox 3"/>
+          <p:cNvSpPr txBox="1"/>
+          <p:nvPr/>
+        </p:nvSpPr>
+        <p:spPr>
+          <a:xfrm>
+            <a:off x="7772400" y="960120"/>
+            <a:ext cx="4114800" cy="5669280"/>
+          </a:xfrm>
+          <a:prstGeom prst="rect">
+            <a:avLst/>
+          </a:prstGeom>
+          <a:noFill/>
+        </p:spPr>
+        <p:txBody>
+          <a:bodyPr wrap="square">
+            <a:spAutoFit/>
+          </a:bodyPr>
+          <a:lstStyle/>
+          <a:p>
+            <a:pPr>
+              <a:spcAft>
+                <a:spcPts val="600"/>
+              </a:spcAft>
+              <a:defRPr sz="1400"/>
+            </a:pPr>
+            <a:r>
+              <a:t>• ⑥ Only students checked under Paying for A.i content are paid. Unchecking a student who left removes them before payment.</a:t>
+            </a:r>
+          </a:p>
+          <a:p>
+            <a:pPr>
+              <a:spcAft>
+                <a:spcPts val="600"/>
+              </a:spcAft>
+              <a:defRPr sz="1400"/>
+            </a:pPr>
+            <a:r>
+              <a:t>• Search by name or ID; Unselect all shown / Select all shown changes many at once (it asks how many first).</a:t>
+            </a:r>
+          </a:p>
+          <a:p>
+            <a:pPr>
+              <a:spcAft>
+                <a:spcPts val="600"/>
+              </a:spcAft>
+              <a:defRPr sz="1400"/>
+            </a:pPr>
+            <a:r>
+              <a:t>• The server recalculates the amount every time a check changes.</a:t>
+            </a:r>
+          </a:p>
+        </p:txBody>
+      </p:sp>
+    </p:spTree>
+  </p:cSld>
+  <p:clrMapOvr>
+    <a:masterClrMapping/>
+  </p:clrMapOvr>
+</p:sld>
+</file>
+
+<file path=ppt/slides/slide56.xml><?xml version="1.0" encoding="utf-8"?>
+<p:sld xmlns:a="http://schemas.openxmlformats.org/drawingml/2006/main" xmlns:p="http://schemas.openxmlformats.org/presentationml/2006/main" xmlns:r="http://schemas.openxmlformats.org/officeDocument/2006/relationships">
+  <p:cSld>
+    <p:spTree>
+      <p:nvGrpSpPr>
+        <p:cNvPr id="1" name=""/>
+        <p:cNvGrpSpPr/>
+        <p:nvPr/>
+      </p:nvGrpSpPr>
+      <p:grpSpPr/>
+      <p:sp>
+        <p:nvSpPr>
+          <p:cNvPr id="2" name="TextBox 1"/>
+          <p:cNvSpPr txBox="1"/>
+          <p:nvPr/>
+        </p:nvSpPr>
+        <p:spPr>
+          <a:xfrm>
+            <a:off x="365760" y="228600"/>
+            <a:ext cx="11430000" cy="640080"/>
+          </a:xfrm>
+          <a:prstGeom prst="rect">
+            <a:avLst/>
+          </a:prstGeom>
+          <a:noFill/>
+        </p:spPr>
+        <p:txBody>
+          <a:bodyPr wrap="square">
+            <a:spAutoFit/>
+          </a:bodyPr>
+          <a:lstStyle/>
+          <a:p>
+            <a:r>
+              <a:rPr sz="2200" b="1">
+                <a:solidFill>
+                  <a:srgbClr val="111827"/>
+                </a:solidFill>
+              </a:rPr>
+              <a:t>10. A.i content payment (agencies) — Not signed up · video-class students</a:t>
+            </a:r>
+          </a:p>
+        </p:txBody>
+      </p:sp>
+      <p:pic>
+        <p:nvPicPr>
+          <p:cNvPr id="3" name="Picture 2" descr="en-p4-notyet.jpg"/>
+          <p:cNvPicPr>
+            <a:picLocks noChangeAspect="1"/>
+          </p:cNvPicPr>
+          <p:nvPr/>
+        </p:nvPicPr>
+        <p:blipFill>
+          <a:blip r:embed="rId2"/>
+          <a:stretch>
+            <a:fillRect/>
+          </a:stretch>
+        </p:blipFill>
+        <p:spPr>
+          <a:xfrm>
+            <a:off x="320040" y="960120"/>
+            <a:ext cx="7223760" cy="1845987"/>
+          </a:xfrm>
+          <a:prstGeom prst="rect">
+            <a:avLst/>
+          </a:prstGeom>
+        </p:spPr>
+      </p:pic>
+      <p:sp>
+        <p:nvSpPr>
+          <p:cNvPr id="4" name="TextBox 3"/>
+          <p:cNvSpPr txBox="1"/>
+          <p:nvPr/>
+        </p:nvSpPr>
+        <p:spPr>
+          <a:xfrm>
+            <a:off x="7772400" y="960120"/>
+            <a:ext cx="4114799" cy="5669280"/>
+          </a:xfrm>
+          <a:prstGeom prst="rect">
+            <a:avLst/>
+          </a:prstGeom>
+          <a:noFill/>
+        </p:spPr>
+        <p:txBody>
+          <a:bodyPr wrap="square">
+            <a:spAutoFit/>
+          </a:bodyPr>
+          <a:lstStyle/>
+          <a:p>
+            <a:pPr>
+              <a:spcAft>
+                <a:spcPts val="600"/>
+              </a:spcAft>
+              <a:defRPr sz="1400"/>
+            </a:pPr>
+            <a:r>
+              <a:t>• ⑦ Checking a student under Not signed up adds them to the payment.</a:t>
+            </a:r>
+          </a:p>
+          <a:p>
+            <a:pPr>
+              <a:spcAft>
+                <a:spcPts val="600"/>
+              </a:spcAft>
+              <a:defRPr sz="1400"/>
+            </a:pPr>
+            <a:r>
+              <a:t>• 📹 Video-class students are folded away. A.i is included in their tuition, so they are not chosen — check one only if the classification is wrong.</a:t>
+            </a:r>
+          </a:p>
+          <a:p>
+            <a:pPr>
+              <a:spcAft>
+                <a:spcPts val="600"/>
+              </a:spcAft>
+              <a:defRPr sz="1400"/>
+            </a:pPr>
+            <a:r>
+              <a:t>• Students the academy changed get a «✔ confirmed by academy» tag, and automatic classification no longer changes them.</a:t>
+            </a:r>
+          </a:p>
+        </p:txBody>
+      </p:sp>
+    </p:spTree>
+  </p:cSld>
+  <p:clrMapOvr>
+    <a:masterClrMapping/>
+  </p:clrMapOvr>
+</p:sld>
+</file>
+
+<file path=ppt/slides/slide57.xml><?xml version="1.0" encoding="utf-8"?>
+<p:sld xmlns:a="http://schemas.openxmlformats.org/drawingml/2006/main" xmlns:p="http://schemas.openxmlformats.org/presentationml/2006/main" xmlns:r="http://schemas.openxmlformats.org/officeDocument/2006/relationships">
+  <p:cSld>
+    <p:spTree>
+      <p:nvGrpSpPr>
+        <p:cNvPr id="1" name=""/>
+        <p:cNvGrpSpPr/>
+        <p:nvPr/>
+      </p:nvGrpSpPr>
+      <p:grpSpPr/>
+      <p:sp>
+        <p:nvSpPr>
+          <p:cNvPr id="2" name="TextBox 1"/>
+          <p:cNvSpPr txBox="1"/>
+          <p:nvPr/>
+        </p:nvSpPr>
+        <p:spPr>
+          <a:xfrm>
+            <a:off x="365760" y="228600"/>
+            <a:ext cx="11430000" cy="640080"/>
+          </a:xfrm>
+          <a:prstGeom prst="rect">
+            <a:avLst/>
+          </a:prstGeom>
+          <a:noFill/>
+        </p:spPr>
+        <p:txBody>
+          <a:bodyPr wrap="square">
+            <a:spAutoFit/>
+          </a:bodyPr>
+          <a:lstStyle/>
+          <a:p>
+            <a:r>
+              <a:rPr sz="2200" b="1">
+                <a:solidFill>
+                  <a:srgbClr val="111827"/>
+                </a:solidFill>
+              </a:rPr>
+              <a:t>10. A.i content payment (agencies) — Check the amount · pay by card</a:t>
+            </a:r>
+          </a:p>
+        </p:txBody>
+      </p:sp>
+      <p:pic>
+        <p:nvPicPr>
+          <p:cNvPr id="3" name="Picture 2" descr="en-p5-pay.jpg"/>
+          <p:cNvPicPr>
+            <a:picLocks noChangeAspect="1"/>
+          </p:cNvPicPr>
+          <p:nvPr/>
+        </p:nvPicPr>
+        <p:blipFill>
+          <a:blip r:embed="rId2"/>
+          <a:stretch>
+            <a:fillRect/>
+          </a:stretch>
+        </p:blipFill>
+        <p:spPr>
+          <a:xfrm>
+            <a:off x="320040" y="960120"/>
+            <a:ext cx="7223760" cy="3209724"/>
+          </a:xfrm>
+          <a:prstGeom prst="rect">
+            <a:avLst/>
+          </a:prstGeom>
+        </p:spPr>
+      </p:pic>
+      <p:sp>
+        <p:nvSpPr>
+          <p:cNvPr id="4" name="TextBox 3"/>
+          <p:cNvSpPr txBox="1"/>
+          <p:nvPr/>
+        </p:nvSpPr>
+        <p:spPr>
+          <a:xfrm>
+            <a:off x="7772400" y="960120"/>
+            <a:ext cx="4114800" cy="5669280"/>
+          </a:xfrm>
+          <a:prstGeom prst="rect">
+            <a:avLst/>
+          </a:prstGeom>
+          <a:noFill/>
+        </p:spPr>
+        <p:txBody>
+          <a:bodyPr wrap="square">
+            <a:spAutoFit/>
+          </a:bodyPr>
+          <a:lstStyle/>
+          <a:p>
+            <a:pPr>
+              <a:spcAft>
+                <a:spcPts val="600"/>
+              </a:spcAft>
+              <a:defRPr sz="1400"/>
+            </a:pPr>
+            <a:r>
+              <a:t>• ⑧ Check the number of students and the total, then ⑨ Pay OOO KRW → confirm → pay in the Toss card window.</a:t>
+            </a:r>
+          </a:p>
+          <a:p>
+            <a:pPr>
+              <a:spcAft>
+                <a:spcPts val="600"/>
+              </a:spcAft>
+              <a:defRPr sz="1400"/>
+            </a:pPr>
+            <a:r>
+              <a:t>• Price per student per month: 20 or fewer 7,500 · 21–50 6,500 · 51–70 5,500 · 71 or more 4,500 KRW. No minimum charge (since 2026-10-26).</a:t>
+            </a:r>
+          </a:p>
+          <a:p>
+            <a:pPr>
+              <a:spcAft>
+                <a:spcPts val="600"/>
+              </a:spcAft>
+              <a:defRPr sz="1400"/>
+            </a:pPr>
+            <a:r>
+              <a:t>• The total never goes down as students are added (e.g. 21–23 students = 150,000 KRW). The server recalculates the amount at the moment of payment — the screen number is for display. Academies with an HQ custom rate pay that rate × students.</a:t>
+            </a:r>
+          </a:p>
+          <a:p>
+            <a:pPr>
+              <a:spcAft>
+                <a:spcPts val="600"/>
+              </a:spcAft>
+              <a:defRPr sz="1400"/>
+            </a:pPr>
+            <a:r>
+              <a:t>• The demo account (testagency) does not open the payment window (sample data).</a:t>
+            </a:r>
+          </a:p>
+        </p:txBody>
+      </p:sp>
+    </p:spTree>
+  </p:cSld>
+  <p:clrMapOvr>
+    <a:masterClrMapping/>
+  </p:clrMapOvr>
+</p:sld>
+</file>
+
+<file path=ppt/slides/slide58.xml><?xml version="1.0" encoding="utf-8"?>
+<p:sld xmlns:a="http://schemas.openxmlformats.org/drawingml/2006/main" xmlns:p="http://schemas.openxmlformats.org/presentationml/2006/main" xmlns:r="http://schemas.openxmlformats.org/officeDocument/2006/relationships">
+  <p:cSld>
+    <p:spTree>
+      <p:nvGrpSpPr>
+        <p:cNvPr id="1" name=""/>
+        <p:cNvGrpSpPr/>
+        <p:nvPr/>
+      </p:nvGrpSpPr>
+      <p:grpSpPr/>
+      <p:sp>
+        <p:nvSpPr>
+          <p:cNvPr id="2" name="TextBox 1"/>
+          <p:cNvSpPr txBox="1"/>
+          <p:nvPr/>
+        </p:nvSpPr>
+        <p:spPr>
+          <a:xfrm>
+            <a:off x="365760" y="228600"/>
+            <a:ext cx="11430000" cy="640080"/>
+          </a:xfrm>
+          <a:prstGeom prst="rect">
+            <a:avLst/>
+          </a:prstGeom>
+          <a:noFill/>
+        </p:spPr>
+        <p:txBody>
+          <a:bodyPr wrap="square">
+            <a:spAutoFit/>
+          </a:bodyPr>
+          <a:lstStyle/>
+          <a:p>
+            <a:r>
+              <a:rPr sz="2200" b="1">
+                <a:solidFill>
+                  <a:srgbClr val="111827"/>
+                </a:solidFill>
+              </a:rPr>
+              <a:t>10. A.i content payment (agencies) — Check the payment · extra payment</a:t>
+            </a:r>
+          </a:p>
+        </p:txBody>
+      </p:sp>
+      <p:pic>
+        <p:nvPicPr>
+          <p:cNvPr id="3" name="Picture 2" descr="en-p6-done.jpg"/>
+          <p:cNvPicPr>
+            <a:picLocks noChangeAspect="1"/>
+          </p:cNvPicPr>
+          <p:nvPr/>
+        </p:nvPicPr>
+        <p:blipFill>
+          <a:blip r:embed="rId2"/>
+          <a:stretch>
+            <a:fillRect/>
+          </a:stretch>
+        </p:blipFill>
+        <p:spPr>
+          <a:xfrm>
+            <a:off x="320040" y="960120"/>
+            <a:ext cx="7223760" cy="1011477"/>
+          </a:xfrm>
+          <a:prstGeom prst="rect">
+            <a:avLst/>
+          </a:prstGeom>
+        </p:spPr>
+      </p:pic>
+      <p:sp>
+        <p:nvSpPr>
+          <p:cNvPr id="4" name="TextBox 3"/>
+          <p:cNvSpPr txBox="1"/>
+          <p:nvPr/>
+        </p:nvSpPr>
+        <p:spPr>
+          <a:xfrm>
+            <a:off x="7772400" y="960120"/>
+            <a:ext cx="4114800" cy="5669280"/>
+          </a:xfrm>
+          <a:prstGeom prst="rect">
+            <a:avLst/>
+          </a:prstGeom>
+          <a:noFill/>
+        </p:spPr>
+        <p:txBody>
+          <a:bodyPr wrap="square">
+            <a:spAutoFit/>
+          </a:bodyPr>
+          <a:lstStyle/>
+          <a:p>
+            <a:pPr>
+              <a:spcAft>
+                <a:spcPts val="600"/>
+              </a:spcAft>
+              <a:defRPr sz="1400"/>
+            </a:pPr>
+            <a:r>
+              <a:t>• ⑩ A ✅ under Past payments means paid. After paying, «Paid» appears and paid students are pinned at the top.</a:t>
+            </a:r>
+          </a:p>
+          <a:p>
+            <a:pPr>
+              <a:spcAft>
+                <a:spcPts val="600"/>
+              </a:spcAft>
+              <a:defRPr sz="1400"/>
+            </a:pPr>
+            <a:r>
+              <a:t>• To add students in the same month, check them below and press Pay extra — only the added students are charged.</a:t>
+            </a:r>
+          </a:p>
+          <a:p>
+            <a:pPr>
+              <a:spcAft>
+                <a:spcPts val="600"/>
+              </a:spcAft>
+              <a:defRPr sz="1400"/>
+            </a:pPr>
+            <a:r>
+              <a:t>• Students already paid for cannot be removed or changed on the screen. HQ handles refunds.</a:t>
+            </a:r>
+          </a:p>
+          <a:p>
+            <a:pPr>
+              <a:spcAft>
+                <a:spcPts val="600"/>
+              </a:spcAft>
+              <a:defRPr sz="1400"/>
+            </a:pPr>
+            <a:r>
+              <a:t>• If an earlier month is unpaid, a «⚠️ Unpaid A.i content invoice(s)» button appears at the top.</a:t>
             </a:r>
           </a:p>
         </p:txBody>

</xml_diff>